<commit_message>
Deck and video: the counsellor agent is built and evaluated in AgentFoundry
Roadmap slide and video scene now show the agent as built (10/10 evals),
with connecting it to the app's chat screen and a school pilot as next.
Architecture slide: the test count is now 23, and the agent plugs into
the counsellor. Video re-rendered at 2:58.
</commit_message>
<xml_diff>
--- a/docs/HPC-Career-Explainer.pptx
+++ b/docs/HPC-Career-Explainer.pptx
@@ -6267,7 +6267,7 @@
                   <a:schemeClr val="tx1"/>
                 </a:solidFill>
               </a:rPr>
-              <a:t>Scripted today; one function to plug in an AI model.</a:t>
+              <a:t>Scripted in the app; the AgentFoundry agent plugs in here.</a:t>
             </a:r>
             <a:endParaRPr lang="en-US" sz="1200" dirty="0"/>
           </a:p>
@@ -6537,7 +6537,7 @@
                   <a:schemeClr val="accent5"/>
                 </a:solidFill>
               </a:rPr>
-              <a:t>Open source under MIT · github.com/om-1115/hpc-career-agent · 14 automated tests for scoring and the API</a:t>
+              <a:t>Open source under MIT · github.com/om-1115/hpc-career-agent · 23 automated tests for scoring, the API and the agent’s tools</a:t>
             </a:r>
             <a:endParaRPr lang="en-US" sz="900" dirty="0"/>
           </a:p>
@@ -8080,7 +8080,7 @@
                   <a:schemeClr val="tx2"/>
                 </a:solidFill>
               </a:rPr>
-              <a:t>In progress</a:t>
+              <a:t>Built and evaluated</a:t>
             </a:r>
             <a:endParaRPr lang="en-US" sz="1300" dirty="0"/>
           </a:p>
@@ -8152,7 +8152,7 @@
                   <a:schemeClr val="tx1"/>
                 </a:solidFill>
               </a:rPr>
-              <a:t>Built in AgentFoundry: reads the result, finds careers, saves a plan.</a:t>
+              <a:t>In AgentFoundry: reads the result, finds careers, saves a plan. All 10 evals pass.</a:t>
             </a:r>
             <a:endParaRPr lang="en-US" sz="1300" dirty="0"/>
           </a:p>
@@ -8268,7 +8268,7 @@
                   <a:schemeClr val="tx2"/>
                 </a:solidFill>
               </a:rPr>
-              <a:t>Pilot with a school</a:t>
+              <a:t>Into the app, then a pilot</a:t>
             </a:r>
             <a:endParaRPr lang="en-US" sz="1600" dirty="0"/>
           </a:p>
@@ -8304,7 +8304,7 @@
                   <a:schemeClr val="tx1"/>
                 </a:solidFill>
               </a:rPr>
-              <a:t>With a partner school, measuring use and outcomes.</a:t>
+              <a:t>Agent in the app’s chat, then a partner school, measuring use and outcomes.</a:t>
             </a:r>
             <a:endParaRPr lang="en-US" sz="1300" dirty="0"/>
           </a:p>

</xml_diff>

<commit_message>
Open with a profile picker instead of a login form
The app now starts on 'Choose your profile': tap a student or teacher and
go, no password, for now. GET /api/profiles lists them and
POST /api/profiles/open issues the session; password sign-in (/api/login,
scrypt hashes, 5-try lock) stays in the API for when it goes to a school.
The menu's 'Sign out' is now 'Switch profile'.

README, submission draft, deck (slides 6, 13, 17) and the first screenshot
updated to match; 24 tests.
</commit_message>
<xml_diff>
--- a/docs/HPC-Career-Explainer.pptx
+++ b/docs/HPC-Career-Explainer.pptx
@@ -5838,7 +5838,7 @@
                   <a:schemeClr val="tx1"/>
                 </a:solidFill>
               </a:rPr>
-              <a:t>Express API: sign-in, results, class view, counsellor stream.</a:t>
+              <a:t>Express API: profiles, results, class view, counsellor stream.</a:t>
             </a:r>
             <a:endParaRPr lang="en-US" sz="1200" dirty="0"/>
           </a:p>
@@ -6501,7 +6501,7 @@
                   <a:schemeClr val="accent6"/>
                 </a:solidFill>
               </a:rPr>
-              <a:t>Hashed passwords, a 5-try lock, signed sessions, pages gated by role.</a:t>
+              <a:t>Signed sessions, pages gated by role; password sign-in ready for schools.</a:t>
             </a:r>
             <a:endParaRPr lang="en-US" sz="1200" dirty="0"/>
           </a:p>
@@ -6537,7 +6537,7 @@
                   <a:schemeClr val="accent5"/>
                 </a:solidFill>
               </a:rPr>
-              <a:t>Open source under MIT · github.com/om-1115/hpc-career-agent · 23 automated tests for scoring, the API and the agent’s tools</a:t>
+              <a:t>Open source under MIT · github.com/om-1115/hpc-career-agent · 24 automated tests for scoring, the API and the agent’s tools</a:t>
             </a:r>
             <a:endParaRPr lang="en-US" sz="900" dirty="0"/>
           </a:p>
@@ -8616,7 +8616,7 @@
                   <a:schemeClr val="accent4"/>
                 </a:solidFill>
               </a:rPr>
-              <a:t>npm run seed:demo, then sign in as student S001 / student-demo or teacher T001 / teacher-demo</a:t>
+              <a:t>npm run seed:demo, then npm run dev:all, and pick a student or teacher profile</a:t>
             </a:r>
             <a:endParaRPr lang="en-US" sz="1600" dirty="0"/>
           </a:p>
@@ -11444,7 +11444,7 @@
                   <a:schemeClr val="tx2"/>
                 </a:solidFill>
               </a:rPr>
-              <a:t>Sign in</a:t>
+              <a:t>Pick a profile</a:t>
             </a:r>
             <a:endParaRPr lang="en-US" sz="1500" dirty="0"/>
           </a:p>
@@ -11480,7 +11480,7 @@
                   <a:schemeClr val="accent5"/>
                 </a:solidFill>
               </a:rPr>
-              <a:t>With the code the school gives</a:t>
+              <a:t>One tap, no password yet</a:t>
             </a:r>
             <a:endParaRPr lang="en-US" sz="1100" dirty="0"/>
           </a:p>

</xml_diff>

<commit_message>
Video, deck and screenshots show the app as it is now
Video (2:53, Aman): the demo is re-recorded — Asha picks her profile, opens
the Career tab, takes the psychometric test, reads her report, explores
careers — and a new scene shows Live HPC and surveys that end in a
reflection. Narration says 'psychometric test'.

Deck: every app picture re-captured (psychometric test, profile picker,
new report and teacher screens), a new slide 11 on Live HPC and surveys,
slides renumbered, and the title line says 'psychometric test'.

Screenshots 02–16 re-captured from the current app.
</commit_message>
<xml_diff>
--- a/docs/HPC-Career-Explainer.pptx
+++ b/docs/HPC-Career-Explainer.pptx
@@ -15,6 +15,7 @@
     <p:sldId id="263" r:id="rId9"/>
     <p:sldId id="264" r:id="rId10"/>
     <p:sldId id="265" r:id="rId11"/>
+    <p:sldId id="273" r:id="rId24"/>
     <p:sldId id="266" r:id="rId12"/>
     <p:sldId id="267" r:id="rId13"/>
     <p:sldId id="268" r:id="rId14"/>
@@ -2721,7 +2722,7 @@
                   <a:schemeClr val="accent4"/>
                 </a:solidFill>
               </a:rPr>
-              <a:t>HPC Career — the Holistic Progress Card that becomes every student’s career passbook: a 10-minute test, a report they can read, real routes from Class 10, and a record of their whole journey.</a:t>
+              <a:t>HPC Career — the Holistic Progress Card that becomes every student’s career passbook: a 10-minute psychometric test, a report they can read, real routes from Class 10, and a record of their whole journey.</a:t>
             </a:r>
             <a:endParaRPr lang="en-US" sz="1600" dirty="0"/>
           </a:p>
@@ -4881,7 +4882,7 @@
             <a:pPr algn="r"/>
             <a:fld id="{F7021451-1387-4CA6-816F-3879F97B5CBC}" type="slidenum">
               <a:rPr b="0" lang="en-US"/>
-              <a:t>11</a:t>
+              <a:t>12</a:t>
             </a:fld>
             <a:endParaRPr lang="en-US"/>
           </a:p>
@@ -5489,7 +5490,7 @@
             <a:pPr algn="r"/>
             <a:fld id="{F7021451-1387-4CA6-816F-3879F97B5CBC}" type="slidenum">
               <a:rPr b="0" lang="en-US"/>
-              <a:t>12</a:t>
+              <a:t>13</a:t>
             </a:fld>
             <a:endParaRPr lang="en-US"/>
           </a:p>
@@ -6582,7 +6583,7 @@
             <a:pPr algn="r"/>
             <a:fld id="{F7021451-1387-4CA6-816F-3879F97B5CBC}" type="slidenum">
               <a:rPr b="0" lang="en-US"/>
-              <a:t>13</a:t>
+              <a:t>14</a:t>
             </a:fld>
             <a:endParaRPr lang="en-US"/>
           </a:p>
@@ -7242,7 +7243,7 @@
             <a:pPr algn="r"/>
             <a:fld id="{F7021451-1387-4CA6-816F-3879F97B5CBC}" type="slidenum">
               <a:rPr b="0" lang="en-US"/>
-              <a:t>14</a:t>
+              <a:t>15</a:t>
             </a:fld>
             <a:endParaRPr lang="en-US"/>
           </a:p>
@@ -7762,7 +7763,7 @@
             <a:pPr algn="r"/>
             <a:fld id="{F7021451-1387-4CA6-816F-3879F97B5CBC}" type="slidenum">
               <a:rPr b="0" lang="en-US"/>
-              <a:t>15</a:t>
+              <a:t>16</a:t>
             </a:fld>
             <a:endParaRPr lang="en-US"/>
           </a:p>
@@ -8501,7 +8502,7 @@
             <a:pPr algn="r"/>
             <a:fld id="{F7021451-1387-4CA6-816F-3879F97B5CBC}" type="slidenum">
               <a:rPr b="0" lang="en-US"/>
-              <a:t>16</a:t>
+              <a:t>17</a:t>
             </a:fld>
             <a:endParaRPr lang="en-US"/>
           </a:p>
@@ -8708,6 +8709,742 @@
           </a:prstGeom>
         </p:spPr>
       </p:pic>
+    </p:spTree>
+  </p:cSld>
+  <p:clrMapOvr>
+    <a:masterClrMapping/>
+  </p:clrMapOvr>
+</p:sld>
+</file>
+
+<file path=ppt/slides/slide18.xml><?xml version="1.0" encoding="utf-8"?>
+<p:sld xmlns:a="http://schemas.openxmlformats.org/drawingml/2006/main" xmlns:r="http://schemas.openxmlformats.org/officeDocument/2006/relationships" xmlns:p="http://schemas.openxmlformats.org/presentationml/2006/main">
+  <p:cSld name="Slide 10">
+    <p:spTree>
+      <p:nvGrpSpPr>
+        <p:cNvPr id="1" name=""/>
+        <p:cNvGrpSpPr/>
+        <p:nvPr/>
+      </p:nvGrpSpPr>
+      <p:grpSpPr>
+        <a:xfrm>
+          <a:off x="0" y="0"/>
+          <a:ext cx="0" cy="0"/>
+          <a:chOff x="0" y="0"/>
+          <a:chExt cx="0" cy="0"/>
+        </a:xfrm>
+      </p:grpSpPr>
+      <p:sp>
+        <p:nvSpPr>
+          <p:cNvPr id="2" name="Text 0"/>
+          <p:cNvSpPr/>
+          <p:nvPr>
+            <p:ph idx="100" type="title" hasCustomPrompt="1"/>
+          </p:nvPr>
+        </p:nvSpPr>
+        <p:spPr>
+          <a:xfrm>
+            <a:off x="457200" y="274320"/>
+            <a:ext cx="8229600" cy="685800"/>
+          </a:xfrm>
+          <a:prstGeom prst="rect">
+            <a:avLst/>
+          </a:prstGeom>
+          <a:noFill/>
+          <a:ln/>
+        </p:spPr>
+        <p:txBody>
+          <a:bodyPr wrap="square" lIns="0" tIns="0" rIns="0" bIns="0" rtlCol="0" anchor="ctr"/>
+          <a:lstStyle/>
+          <a:p>
+            <a:pPr algn="l" indent="0" marL="0">
+              <a:buNone/>
+            </a:pPr>
+            <a:r>
+              <a:rPr lang="en-US" sz="2800" b="1" dirty="0">
+                <a:solidFill>
+                  <a:schemeClr val="tx2"/>
+                </a:solidFill>
+              </a:rPr>
+              <a:t>Live HPC: the term at a glance, and what to do next</a:t>
+            </a:r>
+            <a:endParaRPr lang="en-US" sz="2800" dirty="0"/>
+          </a:p>
+        </p:txBody>
+      </p:sp>
+      <p:sp>
+        <p:nvSpPr>
+          <p:cNvPr id="3" name="Report summary screen frame"/>
+          <p:cNvSpPr/>
+          <p:nvPr/>
+        </p:nvSpPr>
+        <p:spPr>
+          <a:xfrm>
+            <a:off x="420624" y="1060704"/>
+            <a:ext cx="1593598" cy="3364992"/>
+          </a:xfrm>
+          <a:prstGeom prst="roundRect">
+            <a:avLst>
+              <a:gd name="adj" fmla="val 9181"/>
+            </a:avLst>
+          </a:prstGeom>
+          <a:solidFill>
+            <a:schemeClr val="bg1"/>
+          </a:solidFill>
+          <a:ln w="12700">
+            <a:solidFill>
+              <a:srgbClr val="DBEAFE"/>
+            </a:solidFill>
+            <a:prstDash val="solid"/>
+          </a:ln>
+          <a:effectLst>
+            <a:outerShdw sx="100000" sy="100000" kx="0" ky="0" algn="bl" rotWithShape="0" blurRad="127000" dist="38100" dir="5400000">
+              <a:srgbClr val="0F172A">
+                <a:alpha val="18000"/>
+              </a:srgbClr>
+            </a:outerShdw>
+          </a:effectLst>
+        </p:spPr>
+      </p:sp>
+      <p:pic>
+        <p:nvPicPr>
+          <p:cNvPr id="4" name="Report summary screen" descr="Report summary screen">    </p:cNvPr>
+          <p:cNvPicPr>
+            <a:picLocks noChangeAspect="1"/>
+          </p:cNvPicPr>
+          <p:nvPr/>
+        </p:nvPicPr>
+        <p:blipFill>
+          <a:blip r:embed="rId1"/>
+          <a:stretch>
+            <a:fillRect/>
+          </a:stretch>
+        </p:blipFill>
+        <p:spPr>
+          <a:xfrm>
+            <a:off x="457200" y="1097280"/>
+            <a:ext cx="1520446" cy="3291840"/>
+          </a:xfrm>
+          <a:prstGeom prst="rect">
+            <a:avLst/>
+          </a:prstGeom>
+        </p:spPr>
+      </p:pic>
+      <p:sp>
+        <p:nvSpPr>
+          <p:cNvPr id="5" name="Report careers screen frame"/>
+          <p:cNvSpPr/>
+          <p:nvPr/>
+        </p:nvSpPr>
+        <p:spPr>
+          <a:xfrm>
+            <a:off x="2112264" y="1289304"/>
+            <a:ext cx="1488012" cy="3136392"/>
+          </a:xfrm>
+          <a:prstGeom prst="roundRect">
+            <a:avLst>
+              <a:gd name="adj" fmla="val 9832"/>
+            </a:avLst>
+          </a:prstGeom>
+          <a:solidFill>
+            <a:schemeClr val="bg1"/>
+          </a:solidFill>
+          <a:ln w="12700">
+            <a:solidFill>
+              <a:srgbClr val="DBEAFE"/>
+            </a:solidFill>
+            <a:prstDash val="solid"/>
+          </a:ln>
+          <a:effectLst>
+            <a:outerShdw sx="100000" sy="100000" kx="0" ky="0" algn="bl" rotWithShape="0" blurRad="127000" dist="38100" dir="5400000">
+              <a:srgbClr val="0F172A">
+                <a:alpha val="18000"/>
+              </a:srgbClr>
+            </a:outerShdw>
+          </a:effectLst>
+        </p:spPr>
+      </p:sp>
+      <p:pic>
+        <p:nvPicPr>
+          <p:cNvPr id="6" name="Report careers screen" descr="Report careers screen">    </p:cNvPr>
+          <p:cNvPicPr>
+            <a:picLocks noChangeAspect="1"/>
+          </p:cNvPicPr>
+          <p:nvPr/>
+        </p:nvPicPr>
+        <p:blipFill>
+          <a:blip r:embed="rId2"/>
+          <a:stretch>
+            <a:fillRect/>
+          </a:stretch>
+        </p:blipFill>
+        <p:spPr>
+          <a:xfrm>
+            <a:off x="2148840" y="1325880"/>
+            <a:ext cx="1414860" cy="3063240"/>
+          </a:xfrm>
+          <a:prstGeom prst="rect">
+            <a:avLst/>
+          </a:prstGeom>
+        </p:spPr>
+      </p:pic>
+      <p:sp>
+        <p:nvSpPr>
+          <p:cNvPr id="7" name="report point 1 marker"/>
+          <p:cNvSpPr/>
+          <p:nvPr/>
+        </p:nvSpPr>
+        <p:spPr>
+          <a:xfrm>
+            <a:off x="4160520" y="1133856"/>
+            <a:ext cx="329184" cy="329184"/>
+          </a:xfrm>
+          <a:prstGeom prst="ellipse">
+            <a:avLst/>
+          </a:prstGeom>
+          <a:solidFill>
+            <a:schemeClr val="accent1"/>
+          </a:solidFill>
+          <a:ln/>
+        </p:spPr>
+      </p:sp>
+      <p:sp>
+        <p:nvSpPr>
+          <p:cNvPr id="8" name="Text 4"/>
+          <p:cNvSpPr txBox="1"/>
+          <p:nvPr/>
+        </p:nvSpPr>
+        <p:spPr>
+          <a:xfrm>
+            <a:off x="4160520" y="1133856"/>
+            <a:ext cx="329184" cy="329184"/>
+          </a:xfrm>
+          <a:prstGeom prst="rect">
+            <a:avLst/>
+          </a:prstGeom>
+          <a:noFill/>
+          <a:ln/>
+        </p:spPr>
+        <p:txBody>
+          <a:bodyPr wrap="square" lIns="0" tIns="0" rIns="0" bIns="0" rtlCol="0" anchor="ctr"/>
+          <a:lstStyle/>
+          <a:p>
+            <a:pPr algn="ctr" indent="0" marL="0">
+              <a:buNone/>
+            </a:pPr>
+            <a:r>
+              <a:rPr lang="en-US" sz="1300" b="1" dirty="0">
+                <a:solidFill>
+                  <a:schemeClr val="bg1"/>
+                </a:solidFill>
+              </a:rPr>
+              <a:t>1</a:t>
+            </a:r>
+            <a:endParaRPr lang="en-US" sz="1300" dirty="0"/>
+          </a:p>
+        </p:txBody>
+      </p:sp>
+      <p:sp>
+        <p:nvSpPr>
+          <p:cNvPr id="9" name="Text 5"/>
+          <p:cNvSpPr txBox="1"/>
+          <p:nvPr/>
+        </p:nvSpPr>
+        <p:spPr>
+          <a:xfrm>
+            <a:off x="4663440" y="1097280"/>
+            <a:ext cx="4023360" cy="292608"/>
+          </a:xfrm>
+          <a:prstGeom prst="rect">
+            <a:avLst/>
+          </a:prstGeom>
+          <a:noFill/>
+          <a:ln/>
+        </p:spPr>
+        <p:txBody>
+          <a:bodyPr wrap="square" lIns="0" tIns="0" rIns="0" bIns="0" rtlCol="0" anchor="ctr"/>
+          <a:lstStyle/>
+          <a:p>
+            <a:pPr indent="0" marL="0">
+              <a:buNone/>
+            </a:pPr>
+            <a:r>
+              <a:rPr lang="en-US" sz="1600" b="1" dirty="0">
+                <a:solidFill>
+                  <a:schemeClr val="tx2"/>
+                </a:solidFill>
+              </a:rPr>
+              <a:t>Charts of the term</a:t>
+            </a:r>
+            <a:endParaRPr lang="en-US" sz="1600" dirty="0"/>
+          </a:p>
+        </p:txBody>
+      </p:sp>
+      <p:sp>
+        <p:nvSpPr>
+          <p:cNvPr id="10" name="Text 6"/>
+          <p:cNvSpPr txBox="1"/>
+          <p:nvPr/>
+        </p:nvSpPr>
+        <p:spPr>
+          <a:xfrm>
+            <a:off x="4663440" y="1389888"/>
+            <a:ext cx="4023360" cy="475488"/>
+          </a:xfrm>
+          <a:prstGeom prst="rect">
+            <a:avLst/>
+          </a:prstGeom>
+          <a:noFill/>
+          <a:ln/>
+        </p:spPr>
+        <p:txBody>
+          <a:bodyPr wrap="square" lIns="0" tIns="0" rIns="0" bIns="0" rtlCol="0" anchor="t"/>
+          <a:lstStyle/>
+          <a:p>
+            <a:pPr indent="0" marL="0">
+              <a:buNone/>
+            </a:pPr>
+            <a:r>
+              <a:rPr lang="en-US" sz="1300" dirty="0">
+                <a:solidFill>
+                  <a:schemeClr val="tx1"/>
+                </a:solidFill>
+              </a:rPr>
+              <a:t>Attendance, growth since last year, and how the student, group and teacher each see a skill.</a:t>
+            </a:r>
+            <a:endParaRPr lang="en-US" sz="1300" dirty="0"/>
+          </a:p>
+        </p:txBody>
+      </p:sp>
+      <p:sp>
+        <p:nvSpPr>
+          <p:cNvPr id="11" name="report point 2 marker"/>
+          <p:cNvSpPr/>
+          <p:nvPr/>
+        </p:nvSpPr>
+        <p:spPr>
+          <a:xfrm>
+            <a:off x="4160520" y="1938528"/>
+            <a:ext cx="329184" cy="329184"/>
+          </a:xfrm>
+          <a:prstGeom prst="ellipse">
+            <a:avLst/>
+          </a:prstGeom>
+          <a:solidFill>
+            <a:schemeClr val="accent1"/>
+          </a:solidFill>
+          <a:ln/>
+        </p:spPr>
+      </p:sp>
+      <p:sp>
+        <p:nvSpPr>
+          <p:cNvPr id="12" name="Text 8"/>
+          <p:cNvSpPr txBox="1"/>
+          <p:nvPr/>
+        </p:nvSpPr>
+        <p:spPr>
+          <a:xfrm>
+            <a:off x="4160520" y="1938528"/>
+            <a:ext cx="329184" cy="329184"/>
+          </a:xfrm>
+          <a:prstGeom prst="rect">
+            <a:avLst/>
+          </a:prstGeom>
+          <a:noFill/>
+          <a:ln/>
+        </p:spPr>
+        <p:txBody>
+          <a:bodyPr wrap="square" lIns="0" tIns="0" rIns="0" bIns="0" rtlCol="0" anchor="ctr"/>
+          <a:lstStyle/>
+          <a:p>
+            <a:pPr algn="ctr" indent="0" marL="0">
+              <a:buNone/>
+            </a:pPr>
+            <a:r>
+              <a:rPr lang="en-US" sz="1300" b="1" dirty="0">
+                <a:solidFill>
+                  <a:schemeClr val="bg1"/>
+                </a:solidFill>
+              </a:rPr>
+              <a:t>2</a:t>
+            </a:r>
+            <a:endParaRPr lang="en-US" sz="1300" dirty="0"/>
+          </a:p>
+        </p:txBody>
+      </p:sp>
+      <p:sp>
+        <p:nvSpPr>
+          <p:cNvPr id="13" name="Text 9"/>
+          <p:cNvSpPr txBox="1"/>
+          <p:nvPr/>
+        </p:nvSpPr>
+        <p:spPr>
+          <a:xfrm>
+            <a:off x="4663440" y="1901952"/>
+            <a:ext cx="4023360" cy="292608"/>
+          </a:xfrm>
+          <a:prstGeom prst="rect">
+            <a:avLst/>
+          </a:prstGeom>
+          <a:noFill/>
+          <a:ln/>
+        </p:spPr>
+        <p:txBody>
+          <a:bodyPr wrap="square" lIns="0" tIns="0" rIns="0" bIns="0" rtlCol="0" anchor="ctr"/>
+          <a:lstStyle/>
+          <a:p>
+            <a:pPr indent="0" marL="0">
+              <a:buNone/>
+            </a:pPr>
+            <a:r>
+              <a:rPr lang="en-US" sz="1600" b="1" dirty="0">
+                <a:solidFill>
+                  <a:schemeClr val="tx2"/>
+                </a:solidFill>
+              </a:rPr>
+              <a:t>Insights that point the way</a:t>
+            </a:r>
+            <a:endParaRPr lang="en-US" sz="1600" dirty="0"/>
+          </a:p>
+        </p:txBody>
+      </p:sp>
+      <p:sp>
+        <p:nvSpPr>
+          <p:cNvPr id="14" name="Text 10"/>
+          <p:cNvSpPr txBox="1"/>
+          <p:nvPr/>
+        </p:nvSpPr>
+        <p:spPr>
+          <a:xfrm>
+            <a:off x="4663440" y="2194560"/>
+            <a:ext cx="4023360" cy="475488"/>
+          </a:xfrm>
+          <a:prstGeom prst="rect">
+            <a:avLst/>
+          </a:prstGeom>
+          <a:noFill/>
+          <a:ln/>
+        </p:spPr>
+        <p:txBody>
+          <a:bodyPr wrap="square" lIns="0" tIns="0" rIns="0" bIns="0" rtlCol="0" anchor="t"/>
+          <a:lstStyle/>
+          <a:p>
+            <a:pPr indent="0" marL="0">
+              <a:buNone/>
+            </a:pPr>
+            <a:r>
+              <a:rPr lang="en-US" sz="1300" dirty="0">
+                <a:solidFill>
+                  <a:schemeClr val="tx1"/>
+                </a:solidFill>
+              </a:rPr>
+              <a:t>Strengths, fastest growth, where views differ, and the next deadline.</a:t>
+            </a:r>
+            <a:endParaRPr lang="en-US" sz="1300" dirty="0"/>
+          </a:p>
+        </p:txBody>
+      </p:sp>
+      <p:sp>
+        <p:nvSpPr>
+          <p:cNvPr id="15" name="report point 3 marker"/>
+          <p:cNvSpPr/>
+          <p:nvPr/>
+        </p:nvSpPr>
+        <p:spPr>
+          <a:xfrm>
+            <a:off x="4160520" y="2743200"/>
+            <a:ext cx="329184" cy="329184"/>
+          </a:xfrm>
+          <a:prstGeom prst="ellipse">
+            <a:avLst/>
+          </a:prstGeom>
+          <a:solidFill>
+            <a:schemeClr val="accent1"/>
+          </a:solidFill>
+          <a:ln/>
+        </p:spPr>
+      </p:sp>
+      <p:sp>
+        <p:nvSpPr>
+          <p:cNvPr id="16" name="Text 12"/>
+          <p:cNvSpPr txBox="1"/>
+          <p:nvPr/>
+        </p:nvSpPr>
+        <p:spPr>
+          <a:xfrm>
+            <a:off x="4160520" y="2743200"/>
+            <a:ext cx="329184" cy="329184"/>
+          </a:xfrm>
+          <a:prstGeom prst="rect">
+            <a:avLst/>
+          </a:prstGeom>
+          <a:noFill/>
+          <a:ln/>
+        </p:spPr>
+        <p:txBody>
+          <a:bodyPr wrap="square" lIns="0" tIns="0" rIns="0" bIns="0" rtlCol="0" anchor="ctr"/>
+          <a:lstStyle/>
+          <a:p>
+            <a:pPr algn="ctr" indent="0" marL="0">
+              <a:buNone/>
+            </a:pPr>
+            <a:r>
+              <a:rPr lang="en-US" sz="1300" b="1" dirty="0">
+                <a:solidFill>
+                  <a:schemeClr val="bg1"/>
+                </a:solidFill>
+              </a:rPr>
+              <a:t>3</a:t>
+            </a:r>
+            <a:endParaRPr lang="en-US" sz="1300" dirty="0"/>
+          </a:p>
+        </p:txBody>
+      </p:sp>
+      <p:sp>
+        <p:nvSpPr>
+          <p:cNvPr id="17" name="Text 13"/>
+          <p:cNvSpPr txBox="1"/>
+          <p:nvPr/>
+        </p:nvSpPr>
+        <p:spPr>
+          <a:xfrm>
+            <a:off x="4663440" y="2706624"/>
+            <a:ext cx="4023360" cy="292608"/>
+          </a:xfrm>
+          <a:prstGeom prst="rect">
+            <a:avLst/>
+          </a:prstGeom>
+          <a:noFill/>
+          <a:ln/>
+        </p:spPr>
+        <p:txBody>
+          <a:bodyPr wrap="square" lIns="0" tIns="0" rIns="0" bIns="0" rtlCol="0" anchor="ctr"/>
+          <a:lstStyle/>
+          <a:p>
+            <a:pPr indent="0" marL="0">
+              <a:buNone/>
+            </a:pPr>
+            <a:r>
+              <a:rPr lang="en-US" sz="1600" b="1" dirty="0">
+                <a:solidFill>
+                  <a:schemeClr val="tx2"/>
+                </a:solidFill>
+              </a:rPr>
+              <a:t>A to-do list on every page</a:t>
+            </a:r>
+            <a:endParaRPr lang="en-US" sz="1600" dirty="0"/>
+          </a:p>
+        </p:txBody>
+      </p:sp>
+      <p:sp>
+        <p:nvSpPr>
+          <p:cNvPr id="18" name="Text 14"/>
+          <p:cNvSpPr txBox="1"/>
+          <p:nvPr/>
+        </p:nvSpPr>
+        <p:spPr>
+          <a:xfrm>
+            <a:off x="4663440" y="2999232"/>
+            <a:ext cx="4023360" cy="475488"/>
+          </a:xfrm>
+          <a:prstGeom prst="rect">
+            <a:avLst/>
+          </a:prstGeom>
+          <a:noFill/>
+          <a:ln/>
+        </p:spPr>
+        <p:txBody>
+          <a:bodyPr wrap="square" lIns="0" tIns="0" rIns="0" bIns="0" rtlCol="0" anchor="t"/>
+          <a:lstStyle/>
+          <a:p>
+            <a:pPr indent="0" marL="0">
+              <a:buNone/>
+            </a:pPr>
+            <a:r>
+              <a:rPr lang="en-US" sz="1300" dirty="0">
+                <a:solidFill>
+                  <a:schemeClr val="tx1"/>
+                </a:solidFill>
+              </a:rPr>
+              <a:t>Small steps to tick off, from project tasks to this month’s focus.</a:t>
+            </a:r>
+            <a:endParaRPr lang="en-US" sz="1300" dirty="0"/>
+          </a:p>
+        </p:txBody>
+      </p:sp>
+      <p:sp>
+        <p:nvSpPr>
+          <p:cNvPr id="19" name="report point 4 marker"/>
+          <p:cNvSpPr/>
+          <p:nvPr/>
+        </p:nvSpPr>
+        <p:spPr>
+          <a:xfrm>
+            <a:off x="4160520" y="3547872"/>
+            <a:ext cx="329184" cy="329184"/>
+          </a:xfrm>
+          <a:prstGeom prst="ellipse">
+            <a:avLst/>
+          </a:prstGeom>
+          <a:solidFill>
+            <a:schemeClr val="accent1"/>
+          </a:solidFill>
+          <a:ln/>
+        </p:spPr>
+      </p:sp>
+      <p:sp>
+        <p:nvSpPr>
+          <p:cNvPr id="20" name="Text 16"/>
+          <p:cNvSpPr txBox="1"/>
+          <p:nvPr/>
+        </p:nvSpPr>
+        <p:spPr>
+          <a:xfrm>
+            <a:off x="4160520" y="3547872"/>
+            <a:ext cx="329184" cy="329184"/>
+          </a:xfrm>
+          <a:prstGeom prst="rect">
+            <a:avLst/>
+          </a:prstGeom>
+          <a:noFill/>
+          <a:ln/>
+        </p:spPr>
+        <p:txBody>
+          <a:bodyPr wrap="square" lIns="0" tIns="0" rIns="0" bIns="0" rtlCol="0" anchor="ctr"/>
+          <a:lstStyle/>
+          <a:p>
+            <a:pPr algn="ctr" indent="0" marL="0">
+              <a:buNone/>
+            </a:pPr>
+            <a:r>
+              <a:rPr lang="en-US" sz="1300" b="1" dirty="0">
+                <a:solidFill>
+                  <a:schemeClr val="bg1"/>
+                </a:solidFill>
+              </a:rPr>
+              <a:t>4</a:t>
+            </a:r>
+            <a:endParaRPr lang="en-US" sz="1300" dirty="0"/>
+          </a:p>
+        </p:txBody>
+      </p:sp>
+      <p:sp>
+        <p:nvSpPr>
+          <p:cNvPr id="21" name="Text 17"/>
+          <p:cNvSpPr txBox="1"/>
+          <p:nvPr/>
+        </p:nvSpPr>
+        <p:spPr>
+          <a:xfrm>
+            <a:off x="4663440" y="3511296"/>
+            <a:ext cx="4023360" cy="292608"/>
+          </a:xfrm>
+          <a:prstGeom prst="rect">
+            <a:avLst/>
+          </a:prstGeom>
+          <a:noFill/>
+          <a:ln/>
+        </p:spPr>
+        <p:txBody>
+          <a:bodyPr wrap="square" lIns="0" tIns="0" rIns="0" bIns="0" rtlCol="0" anchor="ctr"/>
+          <a:lstStyle/>
+          <a:p>
+            <a:pPr indent="0" marL="0">
+              <a:buNone/>
+            </a:pPr>
+            <a:r>
+              <a:rPr lang="en-US" sz="1600" b="1" dirty="0">
+                <a:solidFill>
+                  <a:schemeClr val="tx2"/>
+                </a:solidFill>
+              </a:rPr>
+              <a:t>Surveys that reflect back</a:t>
+            </a:r>
+            <a:endParaRPr lang="en-US" sz="1600" dirty="0"/>
+          </a:p>
+        </p:txBody>
+      </p:sp>
+      <p:sp>
+        <p:nvSpPr>
+          <p:cNvPr id="22" name="Text 18"/>
+          <p:cNvSpPr txBox="1"/>
+          <p:nvPr/>
+        </p:nvSpPr>
+        <p:spPr>
+          <a:xfrm>
+            <a:off x="4663440" y="3803904"/>
+            <a:ext cx="4023360" cy="475488"/>
+          </a:xfrm>
+          <a:prstGeom prst="rect">
+            <a:avLst/>
+          </a:prstGeom>
+          <a:noFill/>
+          <a:ln/>
+        </p:spPr>
+        <p:txBody>
+          <a:bodyPr wrap="square" lIns="0" tIns="0" rIns="0" bIns="0" rtlCol="0" anchor="t"/>
+          <a:lstStyle/>
+          <a:p>
+            <a:pPr indent="0" marL="0">
+              <a:buNone/>
+            </a:pPr>
+            <a:r>
+              <a:rPr lang="en-US" sz="1300" dirty="0">
+                <a:solidFill>
+                  <a:schemeClr val="tx1"/>
+                </a:solidFill>
+              </a:rPr>
+              <a:t>Skills, goals and the future, each ending in a reflection the student edits and keeps.</a:t>
+            </a:r>
+            <a:endParaRPr lang="en-US" sz="1300" dirty="0"/>
+          </a:p>
+        </p:txBody>
+      </p:sp>
+      <p:sp>
+        <p:nvSpPr>
+          <p:cNvPr id="25" name="Slide Number Placeholder 0"/>
+          <p:cNvSpPr>
+            <a:spLocks noGrp="1"/>
+          </p:cNvSpPr>
+          <p:nvPr>
+            <p:ph type="sldNum" sz="quarter" idx="4294967295"/>
+          </p:nvPr>
+        </p:nvSpPr>
+        <p:spPr>
+          <a:xfrm>
+            <a:off x="8321040" y="4773168"/>
+            <a:ext cx="365760" cy="228600"/>
+          </a:xfrm>
+          <a:prstGeom prst="rect">
+            <a:avLst/>
+          </a:prstGeom>
+          <a:extLst>
+            <a:ext uri="{C572A759-6A51-4108-AA02-DFA0A04FC94B}">
+              <ma14:wrappingTextBoxFlag xmlns:ma14="http://schemas.microsoft.com/office/mac/drawingml/2011/main" val="0"/>
+            </a:ext>
+          </a:extLst>
+        </p:spPr>
+        <p:txBody>
+          <a:bodyPr/>
+          <a:lstStyle>
+            <a:lvl1pPr>
+              <a:defRPr sz="900">
+                <a:solidFill>
+                  <a:schemeClr val="accent5"/>
+                </a:solidFill>
+              </a:defRPr>
+            </a:lvl1pPr>
+          </a:lstStyle>
+          <a:p>
+            <a:pPr algn="r"/>
+            <a:fld id="{F7021451-1387-4CA6-816F-3879F97B5CBC}" type="slidenum">
+              <a:rPr b="0" lang="en-US"/>
+              <a:t>11</a:t>
+            </a:fld>
+            <a:endParaRPr lang="en-US"/>
+          </a:p>
+        </p:txBody>
+      </p:sp>
     </p:spTree>
   </p:cSld>
   <p:clrMapOvr>

</xml_diff>

<commit_message>
Deck: try it live, and the pilot being set up
New slide 17: a QR code and link to the live demo (which profiles to tap)
and the pilot plan — a partner school or NGO being confirmed, 15–30
students, one or two class periods, what we measure, and how children's
data is protected. No date promised. The roadmap's Next is now 'a pilot
with a partner school, being set up', and the closing slide links the
live demo. 19 slides.
</commit_message>
<xml_diff>
--- a/docs/HPC-Career-Explainer.pptx
+++ b/docs/HPC-Career-Explainer.pptx
@@ -21,6 +21,7 @@
     <p:sldId id="268" r:id="rId14"/>
     <p:sldId id="269" r:id="rId15"/>
     <p:sldId id="270" r:id="rId16"/>
+    <p:sldId id="274" r:id="rId25"/>
     <p:sldId id="271" r:id="rId17"/>
     <p:sldId id="272" r:id="rId18"/>
   </p:sldIdLst>
@@ -8269,7 +8270,7 @@
                   <a:schemeClr val="tx2"/>
                 </a:solidFill>
               </a:rPr>
-              <a:t>Into the app, then a pilot</a:t>
+              <a:t>A pilot with a partner school</a:t>
             </a:r>
             <a:endParaRPr lang="en-US" sz="1600" dirty="0"/>
           </a:p>
@@ -8305,7 +8306,7 @@
                   <a:schemeClr val="tx1"/>
                 </a:solidFill>
               </a:rPr>
-              <a:t>Agent in the app’s chat, then a partner school, measuring use and outcomes.</a:t>
+              <a:t>Being set up: 15–30 students, measuring use and outcomes. Then the agent in the app’s chat.</a:t>
             </a:r>
             <a:endParaRPr lang="en-US" sz="1300" dirty="0"/>
           </a:p>
@@ -8502,7 +8503,7 @@
             <a:pPr algn="r"/>
             <a:fld id="{F7021451-1387-4CA6-816F-3879F97B5CBC}" type="slidenum">
               <a:rPr b="0" lang="en-US"/>
-              <a:t>17</a:t>
+              <a:t>18</a:t>
             </a:fld>
             <a:endParaRPr lang="en-US"/>
           </a:p>
@@ -8617,7 +8618,7 @@
                   <a:schemeClr val="accent4"/>
                 </a:solidFill>
               </a:rPr>
-              <a:t>npm run seed:demo, then npm run dev:all, and pick a student or teacher profile</a:t>
+              <a:t>Live demo: hpc-career-agent.vercel.app — tap a student or teacher profile, no sign-up</a:t>
             </a:r>
             <a:endParaRPr lang="en-US" sz="1600" dirty="0"/>
           </a:p>
@@ -9440,6 +9441,812 @@
             <a:fld id="{F7021451-1387-4CA6-816F-3879F97B5CBC}" type="slidenum">
               <a:rPr b="0" lang="en-US"/>
               <a:t>11</a:t>
+            </a:fld>
+            <a:endParaRPr lang="en-US"/>
+          </a:p>
+        </p:txBody>
+      </p:sp>
+    </p:spTree>
+  </p:cSld>
+  <p:clrMapOvr>
+    <a:masterClrMapping/>
+  </p:clrMapOvr>
+</p:sld>
+</file>
+
+<file path=ppt/slides/slide19.xml><?xml version="1.0" encoding="utf-8"?>
+<p:sld xmlns:a="http://schemas.openxmlformats.org/drawingml/2006/main" xmlns:r="http://schemas.openxmlformats.org/officeDocument/2006/relationships" xmlns:p="http://schemas.openxmlformats.org/presentationml/2006/main">
+  <p:cSld name="Slide 10">
+    <p:spTree>
+      <p:nvGrpSpPr>
+        <p:cNvPr id="1" name=""/>
+        <p:cNvGrpSpPr/>
+        <p:nvPr/>
+      </p:nvGrpSpPr>
+      <p:grpSpPr>
+        <a:xfrm>
+          <a:off x="0" y="0"/>
+          <a:ext cx="0" cy="0"/>
+          <a:chOff x="0" y="0"/>
+          <a:chExt cx="0" cy="0"/>
+        </a:xfrm>
+      </p:grpSpPr>
+      <p:sp>
+        <p:nvSpPr>
+          <p:cNvPr id="2" name="Text 0"/>
+          <p:cNvSpPr/>
+          <p:nvPr>
+            <p:ph idx="100" type="title" hasCustomPrompt="1"/>
+          </p:nvPr>
+        </p:nvSpPr>
+        <p:spPr>
+          <a:xfrm>
+            <a:off x="457200" y="274320"/>
+            <a:ext cx="8229600" cy="685800"/>
+          </a:xfrm>
+          <a:prstGeom prst="rect">
+            <a:avLst/>
+          </a:prstGeom>
+          <a:noFill/>
+          <a:ln/>
+        </p:spPr>
+        <p:txBody>
+          <a:bodyPr wrap="square" lIns="0" tIns="0" rIns="0" bIns="0" rtlCol="0" anchor="ctr"/>
+          <a:lstStyle/>
+          <a:p>
+            <a:pPr algn="l" indent="0" marL="0">
+              <a:buNone/>
+            </a:pPr>
+            <a:r>
+              <a:rPr lang="en-US" sz="2800" b="1" dirty="0">
+                <a:solidFill>
+                  <a:schemeClr val="tx2"/>
+                </a:solidFill>
+              </a:rPr>
+              <a:t>Try it live, and the pilot we’re setting up</a:t>
+            </a:r>
+            <a:endParaRPr lang="en-US" sz="2800" dirty="0"/>
+          </a:p>
+        </p:txBody>
+      </p:sp>
+      <p:sp>
+        <p:nvSpPr>
+          <p:cNvPr id="3" name="Report summary screen frame"/>
+          <p:cNvSpPr/>
+          <p:nvPr/>
+        </p:nvSpPr>
+        <p:spPr>
+          <a:xfrm>
+            <a:off x="420624" y="1060704"/>
+            <a:ext cx="1593598" cy="3364992"/>
+          </a:xfrm>
+          <a:prstGeom prst="roundRect">
+            <a:avLst>
+              <a:gd name="adj" fmla="val 9181"/>
+            </a:avLst>
+          </a:prstGeom>
+          <a:solidFill>
+            <a:schemeClr val="bg1"/>
+          </a:solidFill>
+          <a:ln w="12700">
+            <a:solidFill>
+              <a:srgbClr val="DBEAFE"/>
+            </a:solidFill>
+            <a:prstDash val="solid"/>
+          </a:ln>
+          <a:effectLst>
+            <a:outerShdw sx="100000" sy="100000" kx="0" ky="0" algn="bl" rotWithShape="0" blurRad="127000" dist="38100" dir="5400000">
+              <a:srgbClr val="0F172A">
+                <a:alpha val="18000"/>
+              </a:srgbClr>
+            </a:outerShdw>
+          </a:effectLst>
+        </p:spPr>
+      </p:sp>
+      <p:pic>
+        <p:nvPicPr>
+          <p:cNvPr id="4" name="QR code for the live demo" descr="QR code linking to https://hpc-career-agent.vercel.app">    </p:cNvPr>
+          <p:cNvPicPr>
+            <a:picLocks noChangeAspect="1"/>
+          </p:cNvPicPr>
+          <p:nvPr/>
+        </p:nvPicPr>
+        <p:blipFill>
+          <a:blip r:embed="rId1"/>
+          <a:stretch>
+            <a:fillRect/>
+          </a:stretch>
+        </p:blipFill>
+        <p:spPr>
+          <a:xfrm>
+            <a:off x="530352" y="1188720"/>
+            <a:ext cx="1371600" cy="1371600"/>
+          </a:xfrm>
+          <a:prstGeom prst="rect">
+            <a:avLst/>
+          </a:prstGeom>
+        </p:spPr>
+      </p:pic>
+      <p:sp>
+        <p:nvSpPr>
+          <p:cNvPr id="90" name="QR caption"/>
+          <p:cNvSpPr txBox="1"/>
+          <p:nvPr/>
+        </p:nvSpPr>
+        <p:spPr>
+          <a:xfrm>
+            <a:off x="493776" y="2697480"/>
+            <a:ext cx="1444752" cy="1600200"/>
+          </a:xfrm>
+          <a:prstGeom prst="rect">
+            <a:avLst/>
+          </a:prstGeom>
+          <a:noFill/>
+          <a:ln/>
+        </p:spPr>
+        <p:txBody>
+          <a:bodyPr wrap="square" lIns="0" tIns="0" rIns="0" bIns="0" rtlCol="0" anchor="t"/>
+          <a:lstStyle/>
+          <a:p>
+            <a:pPr algn="ctr" indent="0" marL="0">
+              <a:spcAft>
+                <a:spcPts val="400"/>
+              </a:spcAft>
+              <a:buNone/>
+            </a:pPr>
+            <a:r>
+              <a:rPr lang="en-US" sz="1300" b="1" dirty="0">
+                <a:solidFill>
+                  <a:schemeClr val="tx2"/>
+                </a:solidFill>
+              </a:rPr>
+              <a:t>Scan to try it</a:t>
+            </a:r>
+          </a:p>
+          <a:p>
+            <a:pPr algn="ctr" indent="0" marL="0">
+              <a:spcAft>
+                <a:spcPts val="400"/>
+              </a:spcAft>
+              <a:buNone/>
+            </a:pPr>
+            <a:r>
+              <a:rPr lang="en-US" sz="780" b="1" dirty="0">
+                <a:solidFill>
+                  <a:schemeClr val="accent1"/>
+                </a:solidFill>
+              </a:rPr>
+              <a:t>hpc-career-agent.vercel.app</a:t>
+            </a:r>
+          </a:p>
+          <a:p>
+            <a:pPr algn="ctr" indent="0" marL="0">
+              <a:spcAft>
+                <a:spcPts val="400"/>
+              </a:spcAft>
+              <a:buNone/>
+            </a:pPr>
+            <a:r>
+              <a:rPr lang="en-US" sz="950" dirty="0">
+                <a:solidFill>
+                  <a:schemeClr val="tx1"/>
+                </a:solidFill>
+              </a:rPr>
+              <a:t>Tap Asha to take the test, Rohan for his passbook and Live HPC, or Meera for the class view.</a:t>
+            </a:r>
+          </a:p>
+        </p:txBody>
+      </p:sp>
+      <p:sp>
+        <p:nvSpPr>
+          <p:cNvPr id="5" name="Report careers screen frame"/>
+          <p:cNvSpPr/>
+          <p:nvPr/>
+        </p:nvSpPr>
+        <p:spPr>
+          <a:xfrm>
+            <a:off x="2112264" y="1289304"/>
+            <a:ext cx="1488012" cy="3136392"/>
+          </a:xfrm>
+          <a:prstGeom prst="roundRect">
+            <a:avLst>
+              <a:gd name="adj" fmla="val 9832"/>
+            </a:avLst>
+          </a:prstGeom>
+          <a:solidFill>
+            <a:schemeClr val="bg1"/>
+          </a:solidFill>
+          <a:ln w="12700">
+            <a:solidFill>
+              <a:srgbClr val="DBEAFE"/>
+            </a:solidFill>
+            <a:prstDash val="solid"/>
+          </a:ln>
+          <a:effectLst>
+            <a:outerShdw sx="100000" sy="100000" kx="0" ky="0" algn="bl" rotWithShape="0" blurRad="127000" dist="38100" dir="5400000">
+              <a:srgbClr val="0F172A">
+                <a:alpha val="18000"/>
+              </a:srgbClr>
+            </a:outerShdw>
+          </a:effectLst>
+        </p:spPr>
+      </p:sp>
+      <p:pic>
+        <p:nvPicPr>
+          <p:cNvPr id="6" name="Choose your profile screen" descr="The app opens on Choose your profile: tap a student or teacher">    </p:cNvPr>
+          <p:cNvPicPr>
+            <a:picLocks noChangeAspect="1"/>
+          </p:cNvPicPr>
+          <p:nvPr/>
+        </p:nvPicPr>
+        <p:blipFill>
+          <a:blip r:embed="rId2"/>
+          <a:stretch>
+            <a:fillRect/>
+          </a:stretch>
+        </p:blipFill>
+        <p:spPr>
+          <a:xfrm>
+            <a:off x="2148840" y="1325880"/>
+            <a:ext cx="1414860" cy="3063240"/>
+          </a:xfrm>
+          <a:prstGeom prst="rect">
+            <a:avLst/>
+          </a:prstGeom>
+        </p:spPr>
+      </p:pic>
+      <p:sp>
+        <p:nvSpPr>
+          <p:cNvPr id="7" name="report point 1 marker"/>
+          <p:cNvSpPr/>
+          <p:nvPr/>
+        </p:nvSpPr>
+        <p:spPr>
+          <a:xfrm>
+            <a:off x="4160520" y="1133856"/>
+            <a:ext cx="329184" cy="329184"/>
+          </a:xfrm>
+          <a:prstGeom prst="ellipse">
+            <a:avLst/>
+          </a:prstGeom>
+          <a:solidFill>
+            <a:schemeClr val="accent1"/>
+          </a:solidFill>
+          <a:ln/>
+        </p:spPr>
+      </p:sp>
+      <p:sp>
+        <p:nvSpPr>
+          <p:cNvPr id="8" name="Text 4"/>
+          <p:cNvSpPr txBox="1"/>
+          <p:nvPr/>
+        </p:nvSpPr>
+        <p:spPr>
+          <a:xfrm>
+            <a:off x="4160520" y="1133856"/>
+            <a:ext cx="329184" cy="329184"/>
+          </a:xfrm>
+          <a:prstGeom prst="rect">
+            <a:avLst/>
+          </a:prstGeom>
+          <a:noFill/>
+          <a:ln/>
+        </p:spPr>
+        <p:txBody>
+          <a:bodyPr wrap="square" lIns="0" tIns="0" rIns="0" bIns="0" rtlCol="0" anchor="ctr"/>
+          <a:lstStyle/>
+          <a:p>
+            <a:pPr algn="ctr" indent="0" marL="0">
+              <a:buNone/>
+            </a:pPr>
+            <a:r>
+              <a:rPr lang="en-US" sz="1300" b="1" dirty="0">
+                <a:solidFill>
+                  <a:schemeClr val="bg1"/>
+                </a:solidFill>
+              </a:rPr>
+              <a:t>1</a:t>
+            </a:r>
+            <a:endParaRPr lang="en-US" sz="1300" dirty="0"/>
+          </a:p>
+        </p:txBody>
+      </p:sp>
+      <p:sp>
+        <p:nvSpPr>
+          <p:cNvPr id="9" name="Text 5"/>
+          <p:cNvSpPr txBox="1"/>
+          <p:nvPr/>
+        </p:nvSpPr>
+        <p:spPr>
+          <a:xfrm>
+            <a:off x="4663440" y="1097280"/>
+            <a:ext cx="4023360" cy="292608"/>
+          </a:xfrm>
+          <a:prstGeom prst="rect">
+            <a:avLst/>
+          </a:prstGeom>
+          <a:noFill/>
+          <a:ln/>
+        </p:spPr>
+        <p:txBody>
+          <a:bodyPr wrap="square" lIns="0" tIns="0" rIns="0" bIns="0" rtlCol="0" anchor="ctr"/>
+          <a:lstStyle/>
+          <a:p>
+            <a:pPr indent="0" marL="0">
+              <a:buNone/>
+            </a:pPr>
+            <a:r>
+              <a:rPr lang="en-US" sz="1600" b="1" dirty="0">
+                <a:solidFill>
+                  <a:schemeClr val="tx2"/>
+                </a:solidFill>
+              </a:rPr>
+              <a:t>A partner school or NGO</a:t>
+            </a:r>
+            <a:endParaRPr lang="en-US" sz="1600" dirty="0"/>
+          </a:p>
+        </p:txBody>
+      </p:sp>
+      <p:sp>
+        <p:nvSpPr>
+          <p:cNvPr id="10" name="Text 6"/>
+          <p:cNvSpPr txBox="1"/>
+          <p:nvPr/>
+        </p:nvSpPr>
+        <p:spPr>
+          <a:xfrm>
+            <a:off x="4663440" y="1389888"/>
+            <a:ext cx="4023360" cy="475488"/>
+          </a:xfrm>
+          <a:prstGeom prst="rect">
+            <a:avLst/>
+          </a:prstGeom>
+          <a:noFill/>
+          <a:ln/>
+        </p:spPr>
+        <p:txBody>
+          <a:bodyPr wrap="square" lIns="0" tIns="0" rIns="0" bIns="0" rtlCol="0" anchor="t"/>
+          <a:lstStyle/>
+          <a:p>
+            <a:pPr indent="0" marL="0">
+              <a:buNone/>
+            </a:pPr>
+            <a:r>
+              <a:rPr lang="en-US" sz="1300" dirty="0">
+                <a:solidFill>
+                  <a:schemeClr val="tx1"/>
+                </a:solidFill>
+              </a:rPr>
+              <a:t>Being confirmed: 15–30 students in Classes 9–12, with their teacher.</a:t>
+            </a:r>
+            <a:endParaRPr lang="en-US" sz="1300" dirty="0"/>
+          </a:p>
+        </p:txBody>
+      </p:sp>
+      <p:sp>
+        <p:nvSpPr>
+          <p:cNvPr id="11" name="report point 2 marker"/>
+          <p:cNvSpPr/>
+          <p:nvPr/>
+        </p:nvSpPr>
+        <p:spPr>
+          <a:xfrm>
+            <a:off x="4160520" y="1938528"/>
+            <a:ext cx="329184" cy="329184"/>
+          </a:xfrm>
+          <a:prstGeom prst="ellipse">
+            <a:avLst/>
+          </a:prstGeom>
+          <a:solidFill>
+            <a:schemeClr val="accent1"/>
+          </a:solidFill>
+          <a:ln/>
+        </p:spPr>
+      </p:sp>
+      <p:sp>
+        <p:nvSpPr>
+          <p:cNvPr id="12" name="Text 8"/>
+          <p:cNvSpPr txBox="1"/>
+          <p:nvPr/>
+        </p:nvSpPr>
+        <p:spPr>
+          <a:xfrm>
+            <a:off x="4160520" y="1938528"/>
+            <a:ext cx="329184" cy="329184"/>
+          </a:xfrm>
+          <a:prstGeom prst="rect">
+            <a:avLst/>
+          </a:prstGeom>
+          <a:noFill/>
+          <a:ln/>
+        </p:spPr>
+        <p:txBody>
+          <a:bodyPr wrap="square" lIns="0" tIns="0" rIns="0" bIns="0" rtlCol="0" anchor="ctr"/>
+          <a:lstStyle/>
+          <a:p>
+            <a:pPr algn="ctr" indent="0" marL="0">
+              <a:buNone/>
+            </a:pPr>
+            <a:r>
+              <a:rPr lang="en-US" sz="1300" b="1" dirty="0">
+                <a:solidFill>
+                  <a:schemeClr val="bg1"/>
+                </a:solidFill>
+              </a:rPr>
+              <a:t>2</a:t>
+            </a:r>
+            <a:endParaRPr lang="en-US" sz="1300" dirty="0"/>
+          </a:p>
+        </p:txBody>
+      </p:sp>
+      <p:sp>
+        <p:nvSpPr>
+          <p:cNvPr id="13" name="Text 9"/>
+          <p:cNvSpPr txBox="1"/>
+          <p:nvPr/>
+        </p:nvSpPr>
+        <p:spPr>
+          <a:xfrm>
+            <a:off x="4663440" y="1901952"/>
+            <a:ext cx="4023360" cy="292608"/>
+          </a:xfrm>
+          <a:prstGeom prst="rect">
+            <a:avLst/>
+          </a:prstGeom>
+          <a:noFill/>
+          <a:ln/>
+        </p:spPr>
+        <p:txBody>
+          <a:bodyPr wrap="square" lIns="0" tIns="0" rIns="0" bIns="0" rtlCol="0" anchor="ctr"/>
+          <a:lstStyle/>
+          <a:p>
+            <a:pPr indent="0" marL="0">
+              <a:buNone/>
+            </a:pPr>
+            <a:r>
+              <a:rPr lang="en-US" sz="1600" b="1" dirty="0">
+                <a:solidFill>
+                  <a:schemeClr val="tx2"/>
+                </a:solidFill>
+              </a:rPr>
+              <a:t>One or two class periods</a:t>
+            </a:r>
+            <a:endParaRPr lang="en-US" sz="1600" dirty="0"/>
+          </a:p>
+        </p:txBody>
+      </p:sp>
+      <p:sp>
+        <p:nvSpPr>
+          <p:cNvPr id="14" name="Text 10"/>
+          <p:cNvSpPr txBox="1"/>
+          <p:nvPr/>
+        </p:nvSpPr>
+        <p:spPr>
+          <a:xfrm>
+            <a:off x="4663440" y="2194560"/>
+            <a:ext cx="4023360" cy="475488"/>
+          </a:xfrm>
+          <a:prstGeom prst="rect">
+            <a:avLst/>
+          </a:prstGeom>
+          <a:noFill/>
+          <a:ln/>
+        </p:spPr>
+        <p:txBody>
+          <a:bodyPr wrap="square" lIns="0" tIns="0" rIns="0" bIns="0" rtlCol="0" anchor="t"/>
+          <a:lstStyle/>
+          <a:p>
+            <a:pPr indent="0" marL="0">
+              <a:buNone/>
+            </a:pPr>
+            <a:r>
+              <a:rPr lang="en-US" sz="1300" dirty="0">
+                <a:solidFill>
+                  <a:schemeClr val="tx1"/>
+                </a:solidFill>
+              </a:rPr>
+              <a:t>The psychometric test, one survey, then their report and Live HPC.</a:t>
+            </a:r>
+            <a:endParaRPr lang="en-US" sz="1300" dirty="0"/>
+          </a:p>
+        </p:txBody>
+      </p:sp>
+      <p:sp>
+        <p:nvSpPr>
+          <p:cNvPr id="15" name="report point 3 marker"/>
+          <p:cNvSpPr/>
+          <p:nvPr/>
+        </p:nvSpPr>
+        <p:spPr>
+          <a:xfrm>
+            <a:off x="4160520" y="2743200"/>
+            <a:ext cx="329184" cy="329184"/>
+          </a:xfrm>
+          <a:prstGeom prst="ellipse">
+            <a:avLst/>
+          </a:prstGeom>
+          <a:solidFill>
+            <a:schemeClr val="accent1"/>
+          </a:solidFill>
+          <a:ln/>
+        </p:spPr>
+      </p:sp>
+      <p:sp>
+        <p:nvSpPr>
+          <p:cNvPr id="16" name="Text 12"/>
+          <p:cNvSpPr txBox="1"/>
+          <p:nvPr/>
+        </p:nvSpPr>
+        <p:spPr>
+          <a:xfrm>
+            <a:off x="4160520" y="2743200"/>
+            <a:ext cx="329184" cy="329184"/>
+          </a:xfrm>
+          <a:prstGeom prst="rect">
+            <a:avLst/>
+          </a:prstGeom>
+          <a:noFill/>
+          <a:ln/>
+        </p:spPr>
+        <p:txBody>
+          <a:bodyPr wrap="square" lIns="0" tIns="0" rIns="0" bIns="0" rtlCol="0" anchor="ctr"/>
+          <a:lstStyle/>
+          <a:p>
+            <a:pPr algn="ctr" indent="0" marL="0">
+              <a:buNone/>
+            </a:pPr>
+            <a:r>
+              <a:rPr lang="en-US" sz="1300" b="1" dirty="0">
+                <a:solidFill>
+                  <a:schemeClr val="bg1"/>
+                </a:solidFill>
+              </a:rPr>
+              <a:t>3</a:t>
+            </a:r>
+            <a:endParaRPr lang="en-US" sz="1300" dirty="0"/>
+          </a:p>
+        </p:txBody>
+      </p:sp>
+      <p:sp>
+        <p:nvSpPr>
+          <p:cNvPr id="17" name="Text 13"/>
+          <p:cNvSpPr txBox="1"/>
+          <p:nvPr/>
+        </p:nvSpPr>
+        <p:spPr>
+          <a:xfrm>
+            <a:off x="4663440" y="2706624"/>
+            <a:ext cx="4023360" cy="292608"/>
+          </a:xfrm>
+          <a:prstGeom prst="rect">
+            <a:avLst/>
+          </a:prstGeom>
+          <a:noFill/>
+          <a:ln/>
+        </p:spPr>
+        <p:txBody>
+          <a:bodyPr wrap="square" lIns="0" tIns="0" rIns="0" bIns="0" rtlCol="0" anchor="ctr"/>
+          <a:lstStyle/>
+          <a:p>
+            <a:pPr indent="0" marL="0">
+              <a:buNone/>
+            </a:pPr>
+            <a:r>
+              <a:rPr lang="en-US" sz="1600" b="1" dirty="0">
+                <a:solidFill>
+                  <a:schemeClr val="tx2"/>
+                </a:solidFill>
+              </a:rPr>
+              <a:t>Real numbers, reported honestly</a:t>
+            </a:r>
+            <a:endParaRPr lang="en-US" sz="1600" dirty="0"/>
+          </a:p>
+        </p:txBody>
+      </p:sp>
+      <p:sp>
+        <p:nvSpPr>
+          <p:cNvPr id="18" name="Text 14"/>
+          <p:cNvSpPr txBox="1"/>
+          <p:nvPr/>
+        </p:nvSpPr>
+        <p:spPr>
+          <a:xfrm>
+            <a:off x="4663440" y="2999232"/>
+            <a:ext cx="4023360" cy="475488"/>
+          </a:xfrm>
+          <a:prstGeom prst="rect">
+            <a:avLst/>
+          </a:prstGeom>
+          <a:noFill/>
+          <a:ln/>
+        </p:spPr>
+        <p:txBody>
+          <a:bodyPr wrap="square" lIns="0" tIns="0" rIns="0" bIns="0" rtlCol="0" anchor="t"/>
+          <a:lstStyle/>
+          <a:p>
+            <a:pPr indent="0" marL="0">
+              <a:buNone/>
+            </a:pPr>
+            <a:r>
+              <a:rPr lang="en-US" sz="1300" dirty="0">
+                <a:solidFill>
+                  <a:schemeClr val="tx1"/>
+                </a:solidFill>
+              </a:rPr>
+              <a:t>How many finish, minutes taken, a 1–5 “describes me” rating, and teacher views.</a:t>
+            </a:r>
+            <a:endParaRPr lang="en-US" sz="1300" dirty="0"/>
+          </a:p>
+        </p:txBody>
+      </p:sp>
+      <p:sp>
+        <p:nvSpPr>
+          <p:cNvPr id="19" name="report point 4 marker"/>
+          <p:cNvSpPr/>
+          <p:nvPr/>
+        </p:nvSpPr>
+        <p:spPr>
+          <a:xfrm>
+            <a:off x="4160520" y="3547872"/>
+            <a:ext cx="329184" cy="329184"/>
+          </a:xfrm>
+          <a:prstGeom prst="ellipse">
+            <a:avLst/>
+          </a:prstGeom>
+          <a:solidFill>
+            <a:schemeClr val="accent1"/>
+          </a:solidFill>
+          <a:ln/>
+        </p:spPr>
+      </p:sp>
+      <p:sp>
+        <p:nvSpPr>
+          <p:cNvPr id="20" name="Text 16"/>
+          <p:cNvSpPr txBox="1"/>
+          <p:nvPr/>
+        </p:nvSpPr>
+        <p:spPr>
+          <a:xfrm>
+            <a:off x="4160520" y="3547872"/>
+            <a:ext cx="329184" cy="329184"/>
+          </a:xfrm>
+          <a:prstGeom prst="rect">
+            <a:avLst/>
+          </a:prstGeom>
+          <a:noFill/>
+          <a:ln/>
+        </p:spPr>
+        <p:txBody>
+          <a:bodyPr wrap="square" lIns="0" tIns="0" rIns="0" bIns="0" rtlCol="0" anchor="ctr"/>
+          <a:lstStyle/>
+          <a:p>
+            <a:pPr algn="ctr" indent="0" marL="0">
+              <a:buNone/>
+            </a:pPr>
+            <a:r>
+              <a:rPr lang="en-US" sz="1300" b="1" dirty="0">
+                <a:solidFill>
+                  <a:schemeClr val="bg1"/>
+                </a:solidFill>
+              </a:rPr>
+              <a:t>4</a:t>
+            </a:r>
+            <a:endParaRPr lang="en-US" sz="1300" dirty="0"/>
+          </a:p>
+        </p:txBody>
+      </p:sp>
+      <p:sp>
+        <p:nvSpPr>
+          <p:cNvPr id="21" name="Text 17"/>
+          <p:cNvSpPr txBox="1"/>
+          <p:nvPr/>
+        </p:nvSpPr>
+        <p:spPr>
+          <a:xfrm>
+            <a:off x="4663440" y="3511296"/>
+            <a:ext cx="4023360" cy="292608"/>
+          </a:xfrm>
+          <a:prstGeom prst="rect">
+            <a:avLst/>
+          </a:prstGeom>
+          <a:noFill/>
+          <a:ln/>
+        </p:spPr>
+        <p:txBody>
+          <a:bodyPr wrap="square" lIns="0" tIns="0" rIns="0" bIns="0" rtlCol="0" anchor="ctr"/>
+          <a:lstStyle/>
+          <a:p>
+            <a:pPr indent="0" marL="0">
+              <a:buNone/>
+            </a:pPr>
+            <a:r>
+              <a:rPr lang="en-US" sz="1600" b="1" dirty="0">
+                <a:solidFill>
+                  <a:schemeClr val="tx2"/>
+                </a:solidFill>
+              </a:rPr>
+              <a:t>Children’s data protected</a:t>
+            </a:r>
+            <a:endParaRPr lang="en-US" sz="1600" dirty="0"/>
+          </a:p>
+        </p:txBody>
+      </p:sp>
+      <p:sp>
+        <p:nvSpPr>
+          <p:cNvPr id="22" name="Text 18"/>
+          <p:cNvSpPr txBox="1"/>
+          <p:nvPr/>
+        </p:nvSpPr>
+        <p:spPr>
+          <a:xfrm>
+            <a:off x="4663440" y="3803904"/>
+            <a:ext cx="4023360" cy="475488"/>
+          </a:xfrm>
+          <a:prstGeom prst="rect">
+            <a:avLst/>
+          </a:prstGeom>
+          <a:noFill/>
+          <a:ln/>
+        </p:spPr>
+        <p:txBody>
+          <a:bodyPr wrap="square" lIns="0" tIns="0" rIns="0" bIns="0" rtlCol="0" anchor="t"/>
+          <a:lstStyle/>
+          <a:p>
+            <a:pPr indent="0" marL="0">
+              <a:buNone/>
+            </a:pPr>
+            <a:r>
+              <a:rPr lang="en-US" sz="1300" dirty="0">
+                <a:solidFill>
+                  <a:schemeClr val="tx1"/>
+                </a:solidFill>
+              </a:rPr>
+              <a:t>A separate pilot copy with student sign-in, parent consent, and no names published.</a:t>
+            </a:r>
+            <a:endParaRPr lang="en-US" sz="1300" dirty="0"/>
+          </a:p>
+        </p:txBody>
+      </p:sp>
+      <p:sp>
+        <p:nvSpPr>
+          <p:cNvPr id="25" name="Slide Number Placeholder 0"/>
+          <p:cNvSpPr>
+            <a:spLocks noGrp="1"/>
+          </p:cNvSpPr>
+          <p:nvPr>
+            <p:ph type="sldNum" sz="quarter" idx="4294967295"/>
+          </p:nvPr>
+        </p:nvSpPr>
+        <p:spPr>
+          <a:xfrm>
+            <a:off x="8321040" y="4773168"/>
+            <a:ext cx="365760" cy="228600"/>
+          </a:xfrm>
+          <a:prstGeom prst="rect">
+            <a:avLst/>
+          </a:prstGeom>
+          <a:extLst>
+            <a:ext uri="{C572A759-6A51-4108-AA02-DFA0A04FC94B}">
+              <ma14:wrappingTextBoxFlag xmlns:ma14="http://schemas.microsoft.com/office/mac/drawingml/2011/main" val="0"/>
+            </a:ext>
+          </a:extLst>
+        </p:spPr>
+        <p:txBody>
+          <a:bodyPr/>
+          <a:lstStyle>
+            <a:lvl1pPr>
+              <a:defRPr sz="900">
+                <a:solidFill>
+                  <a:schemeClr val="accent5"/>
+                </a:solidFill>
+              </a:defRPr>
+            </a:lvl1pPr>
+          </a:lstStyle>
+          <a:p>
+            <a:pPr algn="r"/>
+            <a:fld id="{F7021451-1387-4CA6-816F-3879F97B5CBC}" type="slidenum">
+              <a:rPr b="0" lang="en-US"/>
+              <a:t>17</a:t>
             </a:fld>
             <a:endParaRPr lang="en-US"/>
           </a:p>

</xml_diff>

<commit_message>
Severity: what a blind stream choice costs
Adds the secondary dropout rate (UDISE+ 2025-26) and youth unemployment
figures (India Employment Report 2024, IHD and ILO) to the submission,
the README and a new deck slide 3.
</commit_message>
<xml_diff>
--- a/docs/HPC-Career-Explainer.pptx
+++ b/docs/HPC-Career-Explainer.pptx
@@ -7,6 +7,7 @@
   <p:sldIdLst>
     <p:sldId id="256" r:id="rId2"/>
     <p:sldId id="257" r:id="rId3"/>
+    <p:sldId id="275" r:id="rId26"/>
     <p:sldId id="258" r:id="rId4"/>
     <p:sldId id="259" r:id="rId5"/>
     <p:sldId id="260" r:id="rId6"/>
@@ -3545,7 +3546,7 @@
             <a:pPr algn="r"/>
             <a:fld id="{F7021451-1387-4CA6-816F-3879F97B5CBC}" type="slidenum">
               <a:rPr b="0" lang="en-US"/>
-              <a:t>10</a:t>
+              <a:t>11</a:t>
             </a:fld>
             <a:endParaRPr lang="en-US"/>
           </a:p>
@@ -4883,7 +4884,7 @@
             <a:pPr algn="r"/>
             <a:fld id="{F7021451-1387-4CA6-816F-3879F97B5CBC}" type="slidenum">
               <a:rPr b="0" lang="en-US"/>
-              <a:t>12</a:t>
+              <a:t>13</a:t>
             </a:fld>
             <a:endParaRPr lang="en-US"/>
           </a:p>
@@ -5491,7 +5492,7 @@
             <a:pPr algn="r"/>
             <a:fld id="{F7021451-1387-4CA6-816F-3879F97B5CBC}" type="slidenum">
               <a:rPr b="0" lang="en-US"/>
-              <a:t>13</a:t>
+              <a:t>14</a:t>
             </a:fld>
             <a:endParaRPr lang="en-US"/>
           </a:p>
@@ -6584,7 +6585,7 @@
             <a:pPr algn="r"/>
             <a:fld id="{F7021451-1387-4CA6-816F-3879F97B5CBC}" type="slidenum">
               <a:rPr b="0" lang="en-US"/>
-              <a:t>14</a:t>
+              <a:t>15</a:t>
             </a:fld>
             <a:endParaRPr lang="en-US"/>
           </a:p>
@@ -7244,7 +7245,7 @@
             <a:pPr algn="r"/>
             <a:fld id="{F7021451-1387-4CA6-816F-3879F97B5CBC}" type="slidenum">
               <a:rPr b="0" lang="en-US"/>
-              <a:t>15</a:t>
+              <a:t>16</a:t>
             </a:fld>
             <a:endParaRPr lang="en-US"/>
           </a:p>
@@ -7495,7 +7496,7 @@
                   <a:schemeClr val="bg1"/>
                 </a:solidFill>
               </a:rPr>
-              <a:t>A stream chosen at 15 shapes the next decade; fewer than 1 in 10 low-income students get guidance today.</a:t>
+              <a:t>A stream chosen at 15 shapes the next decade; under 1 in 10 low-income students get guidance, and 83% of India’s unemployed are young.</a:t>
             </a:r>
             <a:endParaRPr lang="en-US" sz="1400" dirty="0"/>
           </a:p>
@@ -7683,7 +7684,7 @@
                   <a:schemeClr val="bg1"/>
                 </a:solidFill>
               </a:rPr>
-              <a:t>A pilot school: students who finish, reports discussed at home, teacher use in subject choice.</a:t>
+              <a:t>A pilot class: careers students can name before vs after, how well the report fits them, results on a public page.</a:t>
             </a:r>
             <a:endParaRPr lang="en-US" sz="1400" dirty="0"/>
           </a:p>
@@ -7764,7 +7765,7 @@
             <a:pPr algn="r"/>
             <a:fld id="{F7021451-1387-4CA6-816F-3879F97B5CBC}" type="slidenum">
               <a:rPr b="0" lang="en-US"/>
-              <a:t>16</a:t>
+              <a:t>17</a:t>
             </a:fld>
             <a:endParaRPr lang="en-US"/>
           </a:p>
@@ -8503,7 +8504,7 @@
             <a:pPr algn="r"/>
             <a:fld id="{F7021451-1387-4CA6-816F-3879F97B5CBC}" type="slidenum">
               <a:rPr b="0" lang="en-US"/>
-              <a:t>18</a:t>
+              <a:t>19</a:t>
             </a:fld>
             <a:endParaRPr lang="en-US"/>
           </a:p>
@@ -9440,7 +9441,7 @@
             <a:pPr algn="r"/>
             <a:fld id="{F7021451-1387-4CA6-816F-3879F97B5CBC}" type="slidenum">
               <a:rPr b="0" lang="en-US"/>
-              <a:t>11</a:t>
+              <a:t>12</a:t>
             </a:fld>
             <a:endParaRPr lang="en-US"/>
           </a:p>
@@ -10246,7 +10247,7 @@
             <a:pPr algn="r"/>
             <a:fld id="{F7021451-1387-4CA6-816F-3879F97B5CBC}" type="slidenum">
               <a:rPr b="0" lang="en-US"/>
-              <a:t>17</a:t>
+              <a:t>18</a:t>
             </a:fld>
             <a:endParaRPr lang="en-US"/>
           </a:p>
@@ -10803,6 +10804,549 @@
 </p:sld>
 </file>
 
+<file path=ppt/slides/slide20.xml><?xml version="1.0" encoding="utf-8"?>
+<p:sld xmlns:a="http://schemas.openxmlformats.org/drawingml/2006/main" xmlns:r="http://schemas.openxmlformats.org/officeDocument/2006/relationships" xmlns:p="http://schemas.openxmlformats.org/presentationml/2006/main">
+  <p:cSld name="Slide 2">
+    <p:spTree>
+      <p:nvGrpSpPr>
+        <p:cNvPr id="1" name=""/>
+        <p:cNvGrpSpPr/>
+        <p:nvPr/>
+      </p:nvGrpSpPr>
+      <p:grpSpPr>
+        <a:xfrm>
+          <a:off x="0" y="0"/>
+          <a:ext cx="0" cy="0"/>
+          <a:chOff x="0" y="0"/>
+          <a:chExt cx="0" cy="0"/>
+        </a:xfrm>
+      </p:grpSpPr>
+      <p:sp>
+        <p:nvSpPr>
+          <p:cNvPr id="2" name="Text 0"/>
+          <p:cNvSpPr/>
+          <p:nvPr>
+            <p:ph idx="100" type="title" hasCustomPrompt="1"/>
+          </p:nvPr>
+        </p:nvSpPr>
+        <p:spPr>
+          <a:xfrm>
+            <a:off x="457200" y="274320"/>
+            <a:ext cx="8229600" cy="685800"/>
+          </a:xfrm>
+          <a:prstGeom prst="rect">
+            <a:avLst/>
+          </a:prstGeom>
+          <a:noFill/>
+          <a:ln/>
+        </p:spPr>
+        <p:txBody>
+          <a:bodyPr wrap="square" lIns="0" tIns="0" rIns="0" bIns="0" rtlCol="0" anchor="ctr"/>
+          <a:lstStyle/>
+          <a:p>
+            <a:pPr algn="l" indent="0" marL="0">
+              <a:buNone/>
+            </a:pPr>
+            <a:r>
+              <a:rPr lang="en-US" sz="2800" b="1" dirty="0">
+                <a:solidFill>
+                  <a:schemeClr val="tx2"/>
+                </a:solidFill>
+              </a:rPr>
+              <a:t>What a blind choice costs: lost students and educated youth without work</a:t>
+            </a:r>
+            <a:endParaRPr lang="en-US" sz="2800" dirty="0"/>
+          </a:p>
+        </p:txBody>
+      </p:sp>
+      <p:sp>
+        <p:nvSpPr>
+          <p:cNvPr id="3" name="stat card 1"/>
+          <p:cNvSpPr/>
+          <p:nvPr/>
+        </p:nvSpPr>
+        <p:spPr>
+          <a:xfrm>
+            <a:off x="457200" y="1188720"/>
+            <a:ext cx="2606040" cy="2971800"/>
+          </a:xfrm>
+          <a:prstGeom prst="roundRect">
+            <a:avLst>
+              <a:gd name="adj" fmla="val 5263"/>
+            </a:avLst>
+          </a:prstGeom>
+          <a:solidFill>
+            <a:schemeClr val="bg2"/>
+          </a:solidFill>
+          <a:ln/>
+        </p:spPr>
+      </p:sp>
+      <p:sp>
+        <p:nvSpPr>
+          <p:cNvPr id="4" name="Text 2"/>
+          <p:cNvSpPr txBox="1"/>
+          <p:nvPr/>
+        </p:nvSpPr>
+        <p:spPr>
+          <a:xfrm>
+            <a:off x="685800" y="1417320"/>
+            <a:ext cx="2240280" cy="822960"/>
+          </a:xfrm>
+          <a:prstGeom prst="rect">
+            <a:avLst/>
+          </a:prstGeom>
+          <a:noFill/>
+          <a:ln/>
+        </p:spPr>
+        <p:txBody>
+          <a:bodyPr wrap="square" lIns="0" tIns="0" rIns="0" bIns="0" rtlCol="0" anchor="ctr"/>
+          <a:lstStyle/>
+          <a:p>
+            <a:pPr indent="0" marL="0">
+              <a:buNone/>
+            </a:pPr>
+            <a:r>
+              <a:rPr lang="en-US" sz="3000" b="1" dirty="0">
+                <a:solidFill>
+                  <a:schemeClr val="tx2"/>
+                </a:solidFill>
+                <a:latin typeface="Arial" pitchFamily="34" charset="0"/>
+                <a:ea typeface="Arial" pitchFamily="34" charset="-122"/>
+                <a:cs typeface="Arial" pitchFamily="34" charset="-120"/>
+              </a:rPr>
+              <a:t>7.0%</a:t>
+            </a:r>
+            <a:endParaRPr lang="en-US" sz="3000" dirty="0"/>
+          </a:p>
+        </p:txBody>
+      </p:sp>
+      <p:sp>
+        <p:nvSpPr>
+          <p:cNvPr id="5" name="Text 3"/>
+          <p:cNvSpPr txBox="1"/>
+          <p:nvPr/>
+        </p:nvSpPr>
+        <p:spPr>
+          <a:xfrm>
+            <a:off x="685800" y="2331720"/>
+            <a:ext cx="2194560" cy="1234440"/>
+          </a:xfrm>
+          <a:prstGeom prst="rect">
+            <a:avLst/>
+          </a:prstGeom>
+          <a:noFill/>
+          <a:ln/>
+        </p:spPr>
+        <p:txBody>
+          <a:bodyPr wrap="square" lIns="0" tIns="0" rIns="0" bIns="0" rtlCol="0" anchor="t"/>
+          <a:lstStyle/>
+          <a:p>
+            <a:pPr indent="0" marL="0">
+              <a:buNone/>
+            </a:pPr>
+            <a:r>
+              <a:rPr lang="en-US" sz="1500" dirty="0">
+                <a:solidFill>
+                  <a:schemeClr val="tx1"/>
+                </a:solidFill>
+              </a:rPr>
+              <a:t>of Class 9–10 students dropped out in 2025-26, the most of any school stage</a:t>
+            </a:r>
+            <a:endParaRPr lang="en-US" sz="1500" dirty="0"/>
+          </a:p>
+        </p:txBody>
+      </p:sp>
+      <p:sp>
+        <p:nvSpPr>
+          <p:cNvPr id="6" name="Text 4"/>
+          <p:cNvSpPr txBox="1"/>
+          <p:nvPr/>
+        </p:nvSpPr>
+        <p:spPr>
+          <a:xfrm>
+            <a:off x="685800" y="3657600"/>
+            <a:ext cx="2194560" cy="320040"/>
+          </a:xfrm>
+          <a:prstGeom prst="rect">
+            <a:avLst/>
+          </a:prstGeom>
+          <a:noFill/>
+          <a:ln/>
+        </p:spPr>
+        <p:txBody>
+          <a:bodyPr wrap="square" lIns="0" tIns="0" rIns="0" bIns="0" rtlCol="0" anchor="ctr"/>
+          <a:lstStyle/>
+          <a:p>
+            <a:pPr indent="0" marL="0">
+              <a:buNone/>
+            </a:pPr>
+            <a:r>
+              <a:rPr lang="en-US" sz="1100" i="1" dirty="0">
+                <a:solidFill>
+                  <a:schemeClr val="accent5"/>
+                </a:solidFill>
+              </a:rPr>
+              <a:t>UDISE+ 2025-26</a:t>
+            </a:r>
+            <a:endParaRPr lang="en-US" sz="1100" dirty="0"/>
+          </a:p>
+        </p:txBody>
+      </p:sp>
+      <p:sp>
+        <p:nvSpPr>
+          <p:cNvPr id="7" name="stat card 2"/>
+          <p:cNvSpPr/>
+          <p:nvPr/>
+        </p:nvSpPr>
+        <p:spPr>
+          <a:xfrm>
+            <a:off x="3246120" y="1188720"/>
+            <a:ext cx="2606040" cy="2971800"/>
+          </a:xfrm>
+          <a:prstGeom prst="roundRect">
+            <a:avLst>
+              <a:gd name="adj" fmla="val 5263"/>
+            </a:avLst>
+          </a:prstGeom>
+          <a:solidFill>
+            <a:schemeClr val="bg2"/>
+          </a:solidFill>
+          <a:ln/>
+        </p:spPr>
+      </p:sp>
+      <p:sp>
+        <p:nvSpPr>
+          <p:cNvPr id="8" name="Text 6"/>
+          <p:cNvSpPr txBox="1"/>
+          <p:nvPr/>
+        </p:nvSpPr>
+        <p:spPr>
+          <a:xfrm>
+            <a:off x="3474720" y="1417320"/>
+            <a:ext cx="2240280" cy="822960"/>
+          </a:xfrm>
+          <a:prstGeom prst="rect">
+            <a:avLst/>
+          </a:prstGeom>
+          <a:noFill/>
+          <a:ln/>
+        </p:spPr>
+        <p:txBody>
+          <a:bodyPr wrap="square" lIns="0" tIns="0" rIns="0" bIns="0" rtlCol="0" anchor="ctr"/>
+          <a:lstStyle/>
+          <a:p>
+            <a:pPr indent="0" marL="0">
+              <a:buNone/>
+            </a:pPr>
+            <a:r>
+              <a:rPr lang="en-US" sz="3000" b="1" dirty="0">
+                <a:solidFill>
+                  <a:schemeClr val="accent1"/>
+                </a:solidFill>
+                <a:latin typeface="Arial" pitchFamily="34" charset="0"/>
+                <a:ea typeface="Arial" pitchFamily="34" charset="-122"/>
+                <a:cs typeface="Arial" pitchFamily="34" charset="-120"/>
+              </a:rPr>
+              <a:t>82.9%</a:t>
+            </a:r>
+            <a:endParaRPr lang="en-US" sz="3000" dirty="0"/>
+          </a:p>
+        </p:txBody>
+      </p:sp>
+      <p:sp>
+        <p:nvSpPr>
+          <p:cNvPr id="9" name="Text 7"/>
+          <p:cNvSpPr txBox="1"/>
+          <p:nvPr/>
+        </p:nvSpPr>
+        <p:spPr>
+          <a:xfrm>
+            <a:off x="3474720" y="2331720"/>
+            <a:ext cx="2194560" cy="1234440"/>
+          </a:xfrm>
+          <a:prstGeom prst="rect">
+            <a:avLst/>
+          </a:prstGeom>
+          <a:noFill/>
+          <a:ln/>
+        </p:spPr>
+        <p:txBody>
+          <a:bodyPr wrap="square" lIns="0" tIns="0" rIns="0" bIns="0" rtlCol="0" anchor="t"/>
+          <a:lstStyle/>
+          <a:p>
+            <a:pPr indent="0" marL="0">
+              <a:buNone/>
+            </a:pPr>
+            <a:r>
+              <a:rPr lang="en-US" sz="1500" dirty="0">
+                <a:solidFill>
+                  <a:schemeClr val="tx1"/>
+                </a:solidFill>
+              </a:rPr>
+              <a:t>of India's unemployed in 2022 were young people, aged 15–29</a:t>
+            </a:r>
+            <a:endParaRPr lang="en-US" sz="1500" dirty="0"/>
+          </a:p>
+        </p:txBody>
+      </p:sp>
+      <p:sp>
+        <p:nvSpPr>
+          <p:cNvPr id="10" name="Text 8"/>
+          <p:cNvSpPr txBox="1"/>
+          <p:nvPr/>
+        </p:nvSpPr>
+        <p:spPr>
+          <a:xfrm>
+            <a:off x="3474720" y="3657600"/>
+            <a:ext cx="2194560" cy="320040"/>
+          </a:xfrm>
+          <a:prstGeom prst="rect">
+            <a:avLst/>
+          </a:prstGeom>
+          <a:noFill/>
+          <a:ln/>
+        </p:spPr>
+        <p:txBody>
+          <a:bodyPr wrap="square" lIns="0" tIns="0" rIns="0" bIns="0" rtlCol="0" anchor="ctr"/>
+          <a:lstStyle/>
+          <a:p>
+            <a:pPr indent="0" marL="0">
+              <a:buNone/>
+            </a:pPr>
+            <a:r>
+              <a:rPr lang="en-US" sz="1100" i="1" dirty="0">
+                <a:solidFill>
+                  <a:schemeClr val="accent5"/>
+                </a:solidFill>
+              </a:rPr>
+              <a:t>India Employment Report 2024</a:t>
+            </a:r>
+            <a:endParaRPr lang="en-US" sz="1100" dirty="0"/>
+          </a:p>
+        </p:txBody>
+      </p:sp>
+      <p:sp>
+        <p:nvSpPr>
+          <p:cNvPr id="11" name="stat card 3"/>
+          <p:cNvSpPr/>
+          <p:nvPr/>
+        </p:nvSpPr>
+        <p:spPr>
+          <a:xfrm>
+            <a:off x="6035040" y="1188720"/>
+            <a:ext cx="2606040" cy="2971800"/>
+          </a:xfrm>
+          <a:prstGeom prst="roundRect">
+            <a:avLst>
+              <a:gd name="adj" fmla="val 5263"/>
+            </a:avLst>
+          </a:prstGeom>
+          <a:solidFill>
+            <a:schemeClr val="bg2"/>
+          </a:solidFill>
+          <a:ln/>
+        </p:spPr>
+      </p:sp>
+      <p:sp>
+        <p:nvSpPr>
+          <p:cNvPr id="12" name="Text 10"/>
+          <p:cNvSpPr txBox="1"/>
+          <p:nvPr/>
+        </p:nvSpPr>
+        <p:spPr>
+          <a:xfrm>
+            <a:off x="6263640" y="1417320"/>
+            <a:ext cx="2240280" cy="822960"/>
+          </a:xfrm>
+          <a:prstGeom prst="rect">
+            <a:avLst/>
+          </a:prstGeom>
+          <a:noFill/>
+          <a:ln/>
+        </p:spPr>
+        <p:txBody>
+          <a:bodyPr wrap="square" lIns="0" tIns="0" rIns="0" bIns="0" rtlCol="0" anchor="ctr"/>
+          <a:lstStyle/>
+          <a:p>
+            <a:pPr indent="0" marL="0">
+              <a:buNone/>
+            </a:pPr>
+            <a:r>
+              <a:rPr lang="en-US" sz="3000" b="1" dirty="0">
+                <a:solidFill>
+                  <a:schemeClr val="accent2"/>
+                </a:solidFill>
+                <a:latin typeface="Arial" pitchFamily="34" charset="0"/>
+                <a:ea typeface="Arial" pitchFamily="34" charset="-122"/>
+                <a:cs typeface="Arial" pitchFamily="34" charset="-120"/>
+              </a:rPr>
+              <a:t>65.7%</a:t>
+            </a:r>
+            <a:endParaRPr lang="en-US" sz="3000" dirty="0"/>
+          </a:p>
+        </p:txBody>
+      </p:sp>
+      <p:sp>
+        <p:nvSpPr>
+          <p:cNvPr id="13" name="Text 11"/>
+          <p:cNvSpPr txBox="1"/>
+          <p:nvPr/>
+        </p:nvSpPr>
+        <p:spPr>
+          <a:xfrm>
+            <a:off x="6263640" y="2331720"/>
+            <a:ext cx="2194560" cy="1234440"/>
+          </a:xfrm>
+          <a:prstGeom prst="rect">
+            <a:avLst/>
+          </a:prstGeom>
+          <a:noFill/>
+          <a:ln/>
+        </p:spPr>
+        <p:txBody>
+          <a:bodyPr wrap="square" lIns="0" tIns="0" rIns="0" bIns="0" rtlCol="0" anchor="t"/>
+          <a:lstStyle/>
+          <a:p>
+            <a:pPr indent="0" marL="0">
+              <a:buNone/>
+            </a:pPr>
+            <a:r>
+              <a:rPr lang="en-US" sz="1500" dirty="0">
+                <a:solidFill>
+                  <a:schemeClr val="tx1"/>
+                </a:solidFill>
+              </a:rPr>
+              <a:t>of the unemployed were young people with secondary education or more</a:t>
+            </a:r>
+            <a:endParaRPr lang="en-US" sz="1500" dirty="0"/>
+          </a:p>
+        </p:txBody>
+      </p:sp>
+      <p:sp>
+        <p:nvSpPr>
+          <p:cNvPr id="14" name="Text 12"/>
+          <p:cNvSpPr txBox="1"/>
+          <p:nvPr/>
+        </p:nvSpPr>
+        <p:spPr>
+          <a:xfrm>
+            <a:off x="6263640" y="3657600"/>
+            <a:ext cx="2194560" cy="320040"/>
+          </a:xfrm>
+          <a:prstGeom prst="rect">
+            <a:avLst/>
+          </a:prstGeom>
+          <a:noFill/>
+          <a:ln/>
+        </p:spPr>
+        <p:txBody>
+          <a:bodyPr wrap="square" lIns="0" tIns="0" rIns="0" bIns="0" rtlCol="0" anchor="ctr"/>
+          <a:lstStyle/>
+          <a:p>
+            <a:pPr indent="0" marL="0">
+              <a:buNone/>
+            </a:pPr>
+            <a:r>
+              <a:rPr lang="en-US" sz="1100" i="1" dirty="0">
+                <a:solidFill>
+                  <a:schemeClr val="accent5"/>
+                </a:solidFill>
+              </a:rPr>
+              <a:t>India Employment Report 2024</a:t>
+            </a:r>
+            <a:endParaRPr lang="en-US" sz="1100" dirty="0"/>
+          </a:p>
+        </p:txBody>
+      </p:sp>
+      <p:sp>
+        <p:nvSpPr>
+          <p:cNvPr id="15" name="Text 13"/>
+          <p:cNvSpPr txBox="1"/>
+          <p:nvPr/>
+        </p:nvSpPr>
+        <p:spPr>
+          <a:xfrm>
+            <a:off x="457200" y="4407408"/>
+            <a:ext cx="8229600" cy="329184"/>
+          </a:xfrm>
+          <a:prstGeom prst="rect">
+            <a:avLst/>
+          </a:prstGeom>
+          <a:noFill/>
+          <a:ln/>
+        </p:spPr>
+        <p:txBody>
+          <a:bodyPr wrap="square" lIns="0" tIns="0" rIns="0" bIns="0" rtlCol="0" anchor="b"/>
+          <a:lstStyle/>
+          <a:p>
+            <a:pPr indent="0" marL="0">
+              <a:buNone/>
+            </a:pPr>
+            <a:r>
+              <a:rPr lang="en-US" sz="900" dirty="0">
+                <a:solidFill>
+                  <a:schemeClr val="accent5"/>
+                </a:solidFill>
+              </a:rPr>
+              <a:t>Sources: Ministry of Education, UDISE+ 2025-26 (PIB, 7 July 2026; secondary dropout was 13.8% in 2022-23) · India Employment Report 2024, Institute for Human Development &amp; ILO (2022 data). Guidance won’t fix the job market, but it lets a student choose a route on purpose.</a:t>
+            </a:r>
+            <a:endParaRPr lang="en-US" sz="900" dirty="0"/>
+          </a:p>
+        </p:txBody>
+      </p:sp>
+      <p:sp>
+        <p:nvSpPr>
+          <p:cNvPr id="25" name="Slide Number Placeholder 0"/>
+          <p:cNvSpPr>
+            <a:spLocks noGrp="1"/>
+          </p:cNvSpPr>
+          <p:nvPr>
+            <p:ph type="sldNum" sz="quarter" idx="4294967295"/>
+          </p:nvPr>
+        </p:nvSpPr>
+        <p:spPr>
+          <a:xfrm>
+            <a:off x="8321040" y="4773168"/>
+            <a:ext cx="365760" cy="228600"/>
+          </a:xfrm>
+          <a:prstGeom prst="rect">
+            <a:avLst/>
+          </a:prstGeom>
+          <a:extLst>
+            <a:ext uri="{C572A759-6A51-4108-AA02-DFA0A04FC94B}">
+              <ma14:wrappingTextBoxFlag xmlns:ma14="http://schemas.microsoft.com/office/mac/drawingml/2011/main" val="0"/>
+            </a:ext>
+          </a:extLst>
+        </p:spPr>
+        <p:txBody>
+          <a:bodyPr/>
+          <a:lstStyle>
+            <a:lvl1pPr>
+              <a:defRPr sz="900">
+                <a:solidFill>
+                  <a:schemeClr val="accent5"/>
+                </a:solidFill>
+              </a:defRPr>
+            </a:lvl1pPr>
+          </a:lstStyle>
+          <a:p>
+            <a:pPr algn="r"/>
+            <a:fld id="{F7021451-1387-4CA6-816F-3879F97B5CBC}" type="slidenum">
+              <a:rPr b="0" lang="en-US"/>
+              <a:t>3</a:t>
+            </a:fld>
+            <a:endParaRPr lang="en-US"/>
+          </a:p>
+        </p:txBody>
+      </p:sp>
+    </p:spTree>
+  </p:cSld>
+  <p:clrMapOvr>
+    <a:masterClrMapping/>
+  </p:clrMapOvr>
+</p:sld>
+</file>
+
 <file path=ppt/slides/slide3.xml><?xml version="1.0" encoding="utf-8"?>
 <p:sld xmlns:a="http://schemas.openxmlformats.org/drawingml/2006/main" xmlns:r="http://schemas.openxmlformats.org/officeDocument/2006/relationships" xmlns:p="http://schemas.openxmlformats.org/presentationml/2006/main">
   <p:cSld name="Slide 3">
@@ -11419,7 +11963,7 @@
             <a:pPr algn="r"/>
             <a:fld id="{F7021451-1387-4CA6-816F-3879F97B5CBC}" type="slidenum">
               <a:rPr b="0" lang="en-US"/>
-              <a:t>3</a:t>
+              <a:t>4</a:t>
             </a:fld>
             <a:endParaRPr lang="en-US"/>
           </a:p>
@@ -12184,7 +12728,7 @@
             <a:pPr algn="r"/>
             <a:fld id="{F7021451-1387-4CA6-816F-3879F97B5CBC}" type="slidenum">
               <a:rPr b="0" lang="en-US"/>
-              <a:t>4</a:t>
+              <a:t>5</a:t>
             </a:fld>
             <a:endParaRPr lang="en-US"/>
           </a:p>
@@ -12770,7 +13314,7 @@
             <a:pPr algn="r"/>
             <a:fld id="{F7021451-1387-4CA6-816F-3879F97B5CBC}" type="slidenum">
               <a:rPr b="0" lang="en-US"/>
-              <a:t>5</a:t>
+              <a:t>6</a:t>
             </a:fld>
             <a:endParaRPr lang="en-US"/>
           </a:p>
@@ -13642,7 +14186,7 @@
             <a:pPr algn="r"/>
             <a:fld id="{F7021451-1387-4CA6-816F-3879F97B5CBC}" type="slidenum">
               <a:rPr b="0" lang="en-US"/>
-              <a:t>6</a:t>
+              <a:t>7</a:t>
             </a:fld>
             <a:endParaRPr lang="en-US"/>
           </a:p>
@@ -15022,7 +15566,7 @@
             <a:pPr algn="r"/>
             <a:fld id="{F7021451-1387-4CA6-816F-3879F97B5CBC}" type="slidenum">
               <a:rPr b="0" lang="en-US"/>
-              <a:t>7</a:t>
+              <a:t>8</a:t>
             </a:fld>
             <a:endParaRPr lang="en-US"/>
           </a:p>
@@ -15710,7 +16254,7 @@
             <a:pPr algn="r"/>
             <a:fld id="{F7021451-1387-4CA6-816F-3879F97B5CBC}" type="slidenum">
               <a:rPr b="0" lang="en-US"/>
-              <a:t>8</a:t>
+              <a:t>9</a:t>
             </a:fld>
             <a:endParaRPr lang="en-US"/>
           </a:p>
@@ -16352,7 +16896,7 @@
             <a:pPr algn="r"/>
             <a:fld id="{F7021451-1387-4CA6-816F-3879F97B5CBC}" type="slidenum">
               <a:rPr b="0" lang="en-US"/>
-              <a:t>9</a:t>
+              <a:t>10</a:t>
             </a:fld>
             <a:endParaRPr lang="en-US"/>
           </a:p>

</xml_diff>